<commit_message>
Add publication-grade PDF; correct hash narrative (Phase-1 mock vs Phase-2 IPFS/SHA-256)
</commit_message>
<xml_diff>
--- a/UniVerify_V2.0.pptx
+++ b/UniVerify_V2.0.pptx
@@ -4444,7 +4444,7 @@
                 </a:solidFill>
                 <a:latin typeface="Segoe UI"/>
               </a:rPr>
-              <a:t>Off-chain Storage  </a:t>
+              <a:t>Data Fingerprint  </a:t>
             </a:r>
           </a:p>
           <a:p>
@@ -4460,7 +4460,7 @@
                 </a:solidFill>
                 <a:latin typeface="Consolas"/>
               </a:rPr>
-              <a:t>IPFS (hash anchored on-chain)</a:t>
+              <a:t>Manual mock string (IPFS/SHA-256 in P2)</a:t>
             </a:r>
           </a:p>
         </p:txBody>
@@ -8316,7 +8316,7 @@
                 </a:solidFill>
                 <a:latin typeface="Consolas"/>
               </a:rPr>
-              <a:t>STORAGE</a:t>
+              <a:t>HASH FIELD</a:t>
             </a:r>
           </a:p>
           <a:p>
@@ -8332,7 +8332,7 @@
                 </a:solidFill>
                 <a:latin typeface="Segoe UI"/>
               </a:rPr>
-              <a:t>IPFS hash anchoring</a:t>
+              <a:t>Manual mock string (P1)</a:t>
             </a:r>
           </a:p>
         </p:txBody>
@@ -11012,7 +11012,7 @@
                 </a:solidFill>
                 <a:latin typeface="Segoe UI"/>
               </a:rPr>
-              <a:t>Bundles studentName, courseName &amp; IPFS hash.</a:t>
+              <a:t>Bundles studentName, courseName &amp; a hash-string field.</a:t>
             </a:r>
           </a:p>
         </p:txBody>
@@ -15145,7 +15145,7 @@
                 </a:solidFill>
                 <a:latin typeface="Segoe UI"/>
               </a:rPr>
-              <a:t>Name · Course · IPFS hash</a:t>
+              <a:t>Name · Course · hash-string field</a:t>
             </a:r>
           </a:p>
         </p:txBody>

</xml_diff>